<commit_message>
[shapes] gradients, shadows; pictures turned, flipped and cut to their shapes
pd_draw: fill2/grad/grad_angle (a linear or radial gradient from fill to
fill2), rotation/flip and clip_points for images. The DOCX/PPTX drawing
reader takes a gradient's first and last stops and its direction, an outer
shadow (drawn as the shape's outline filled, offset), a picture's turn and
flips, and a picture's geometry when it is not a rectangle (cut to it). PDF:
gradients as fine bands inside the path, images turned and clipped.

Fixed: a picture used twice in a drawing named its id twice in the drawing's
description, which a strict JSON reader rejects (the whole drawing lost).

Co-Authored-By: Claude Opus 5.5 <noreply@anthropic.com>
</commit_message>
<xml_diff>
--- a/tests/data/slides.pptx
+++ b/tests/data/slides.pptx
@@ -314,6 +314,40 @@
       </p:cxnSp>
       <p:sp>
         <p:nvSpPr>
+          <p:cNvPr id="8" name="Gradient"/>
+          <p:cNvSpPr/>
+          <p:nvPr/>
+        </p:nvSpPr>
+        <p:spPr>
+          <a:xfrm>
+            <a:off x="500000" y="3000000"/>
+            <a:ext cx="1500000" cy="800000"/>
+          </a:xfrm>
+          <a:prstGeom prst="rect">
+            <a:avLst/>
+          </a:prstGeom>
+          <a:gradFill>
+            <a:gsLst>
+              <a:gs pos="0">
+                <a:srgbClr val="FF0000"/>
+              </a:gs>
+              <a:gs pos="100000">
+                <a:srgbClr val="0000FF"/>
+              </a:gs>
+            </a:gsLst>
+            <a:lin ang="0" scaled="0"/>
+          </a:gradFill>
+          <a:effectLst>
+            <a:outerShdw blurRad="40000" dist="38100" dir="2700000">
+              <a:srgbClr val="000000">
+                <a:alpha val="40000"/>
+              </a:srgbClr>
+            </a:outerShdw>
+          </a:effectLst>
+        </p:spPr>
+      </p:sp>
+      <p:sp>
+        <p:nvSpPr>
           <p:cNvPr id="7" name="Number"/>
           <p:cNvSpPr/>
           <p:nvPr>
@@ -371,6 +405,28 @@
             <a:ext cx="2000000" cy="2000000"/>
           </a:xfrm>
           <a:prstGeom prst="rect">
+            <a:avLst/>
+          </a:prstGeom>
+        </p:spPr>
+      </p:pic>
+      <p:pic>
+        <p:nvPicPr>
+          <p:cNvPr id="4" name="Turned"/>
+          <p:cNvPicPr/>
+          <p:nvPr/>
+        </p:nvPicPr>
+        <p:blipFill>
+          <a:blip r:embed="rId2"/>
+          <a:stretch>
+            <a:fillRect/>
+          </a:stretch>
+        </p:blipFill>
+        <p:spPr>
+          <a:xfrm rot="2700000" flipH="1">
+            <a:off x="500000" y="3000000"/>
+            <a:ext cx="1200000" cy="900000"/>
+          </a:xfrm>
+          <a:prstGeom prst="ellipse">
             <a:avLst/>
           </a:prstGeom>
         </p:spPr>

</xml_diff>